<commit_message>
Strengthen judge proof and bounded AI
</commit_message>
<xml_diff>
--- a/docs/CreekReady-Iris-Hacks-IV.pptx
+++ b/docs/CreekReady-Iris-Hacks-IV.pptx
@@ -2,17 +2,17 @@
 <file path=ppt/presentation.xml><?xml version="1.0" encoding="utf-8"?>
 <p:presentation xmlns:p="http://schemas.openxmlformats.org/presentationml/2006/main">
   <p:sldMasterIdLst>
-    <p:sldMasterId xmlns:r="http://schemas.openxmlformats.org/officeDocument/2006/relationships" id="2147483648" r:id="Rce2df2d1f9594b0a"/>
+    <p:sldMasterId xmlns:r="http://schemas.openxmlformats.org/officeDocument/2006/relationships" id="2147483648" r:id="R72d58576b1ed401c"/>
   </p:sldMasterIdLst>
   <p:notesMasterIdLst>
-    <p:notesMasterId xmlns:r="http://schemas.openxmlformats.org/officeDocument/2006/relationships" r:id="R419106ea02324f63"/>
+    <p:notesMasterId xmlns:r="http://schemas.openxmlformats.org/officeDocument/2006/relationships" r:id="Rba19e8051aeb4ddb"/>
   </p:notesMasterIdLst>
   <p:sldIdLst>
-    <p:sldId xmlns:r="http://schemas.openxmlformats.org/officeDocument/2006/relationships" id="256" r:id="Rc4f80346e5254661"/>
-    <p:sldId xmlns:r="http://schemas.openxmlformats.org/officeDocument/2006/relationships" id="257" r:id="Ra1d0c82cece04151"/>
-    <p:sldId xmlns:r="http://schemas.openxmlformats.org/officeDocument/2006/relationships" id="258" r:id="Racf9469d01b94ced"/>
-    <p:sldId xmlns:r="http://schemas.openxmlformats.org/officeDocument/2006/relationships" id="259" r:id="Rfb4c7594978948ce"/>
-    <p:sldId xmlns:r="http://schemas.openxmlformats.org/officeDocument/2006/relationships" id="260" r:id="Rcbd4b664cb85458a"/>
+    <p:sldId xmlns:r="http://schemas.openxmlformats.org/officeDocument/2006/relationships" id="256" r:id="Rd7030887d06f49fd"/>
+    <p:sldId xmlns:r="http://schemas.openxmlformats.org/officeDocument/2006/relationships" id="257" r:id="R92ac9aa7b25746bb"/>
+    <p:sldId xmlns:r="http://schemas.openxmlformats.org/officeDocument/2006/relationships" id="258" r:id="R728abd75349144ba"/>
+    <p:sldId xmlns:r="http://schemas.openxmlformats.org/officeDocument/2006/relationships" id="259" r:id="Ref5e76c729b14589"/>
+    <p:sldId xmlns:r="http://schemas.openxmlformats.org/officeDocument/2006/relationships" id="260" r:id="R4dce75e563294d75"/>
   </p:sldIdLst>
   <p:sldSz cx="12192000" cy="6858000"/>
   <p:notesSz cx="6858000" cy="9144000"/>
@@ -641,7 +641,7 @@
           <a:lstStyle xmlns:a="http://schemas.openxmlformats.org/drawingml/2006/main"/>
           <a:p xmlns:a="http://schemas.openxmlformats.org/drawingml/2006/main">
             <a:r>
-              <a:t>0:32–1:08 — Paste a sample official alert, select practical household constraints, and generate. The app extracts the displayed fact panel deterministically. The result then organizes actions into Now, Next, and If conditions worsen, with source IDs retained.</a:t>
+              <a:t>0:32–1:08 — This is a real CreekReady result from the fictional wildfire sample with older adult and pet selected. The first view exposes the Featherless-ranked mode, household fit, all three decision stages, and source IDs; the deterministic fact panel and bounded-AI receipt remain inspectable below.</a:t>
             </a:r>
           </a:p>
           <a:p xmlns:a="http://schemas.openxmlformats.org/drawingml/2006/main">
@@ -656,17 +656,17 @@
           </a:p>
           <a:p xmlns:a="http://schemas.openxmlformats.org/drawingml/2006/main">
             <a:r>
-              <a:t>- README.md — demonstrated end-to-end workflow and current limitations.</a:t>
-            </a:r>
-          </a:p>
-          <a:p xmlns:a="http://schemas.openxmlformats.org/drawingml/2006/main">
-            <a:r>
-              <a:t>- creekready/service.py — planning service and deterministic fact-panel ownership.</a:t>
-            </a:r>
-          </a:p>
-          <a:p xmlns:a="http://schemas.openxmlformats.org/drawingml/2006/main">
-            <a:r>
-              <a:t>- creekready/fallback.py — staged fallback action construction.</a:t>
+              <a:t>- docs/assets/creekready-desktop-result.png — real local CreekReady interface capture using a fictional sample; not a live warning.</a:t>
+            </a:r>
+          </a:p>
+          <a:p xmlns:a="http://schemas.openxmlformats.org/drawingml/2006/main">
+            <a:r>
+              <a:t>- README.md — demonstrated workflow, modes, and current limitations.</a:t>
+            </a:r>
+          </a:p>
+          <a:p xmlns:a="http://schemas.openxmlformats.org/drawingml/2006/main">
+            <a:r>
+              <a:t>- creekready/service.py; creekready/provider.py; creekready/catalog.py — deterministic fact ownership, bounded ranking, and vetted action catalog.</a:t>
             </a:r>
           </a:p>
           <a:p xmlns:a="http://schemas.openxmlformats.org/drawingml/2006/main">
@@ -746,7 +746,7 @@
           <a:lstStyle xmlns:a="http://schemas.openxmlformats.org/drawingml/2006/main"/>
           <a:p xmlns:a="http://schemas.openxmlformats.org/drawingml/2006/main">
             <a:r>
-              <a:t>1:08–1:38 — This is the key engineering boundary. When enabled, Featherless receives the pasted alert plus a vetted action catalog and returns only ordered action IDs. Displayed facts come from deterministic extraction, and schema and source checks fail closed to a clearly labeled fallback.</a:t>
+              <a:t>1:08–1:38 — This is the key engineering boundary. Featherless receives parser-selected directive sentences, selected needs/language, and a vetted action catalog, then returns two prose-free ID arrays: prioritized instruction IDs and ranked action IDs. Displayed facts and all visible wording remain server-owned; invalid output fails closed to the deterministic fallback.</a:t>
             </a:r>
           </a:p>
           <a:p xmlns:a="http://schemas.openxmlformats.org/drawingml/2006/main">
@@ -761,22 +761,22 @@
           </a:p>
           <a:p xmlns:a="http://schemas.openxmlformats.org/drawingml/2006/main">
             <a:r>
-              <a:t>- creekready/service.py — deterministic fact panel, provider selection, and fallback behavior.</a:t>
-            </a:r>
-          </a:p>
-          <a:p xmlns:a="http://schemas.openxmlformats.org/drawingml/2006/main">
-            <a:r>
-              <a:t>- creekready/provider.py; creekready/catalog.py — Featherless ranking contract, vetted action catalog, and fail-closed selection validation.</a:t>
-            </a:r>
-          </a:p>
-          <a:p xmlns:a="http://schemas.openxmlformats.org/drawingml/2006/main">
-            <a:r>
-              <a:t>- creekready/models.py; creekready/sources.py — bounded response contracts and official-source allowlist.</a:t>
-            </a:r>
-          </a:p>
-          <a:p xmlns:a="http://schemas.openxmlformats.org/drawingml/2006/main">
-            <a:r>
-              <a:t>- README.md — privacy statement, modes, and provider behavior.</a:t>
+              <a:t>- creekready/service.py — deterministic fact panel, server-owned stage and visible wording, provider selection, required-action restoration, and fallback behavior.</a:t>
+            </a:r>
+          </a:p>
+          <a:p xmlns:a="http://schemas.openxmlformats.org/drawingml/2006/main">
+            <a:r>
+              <a:t>- creekready/provider.py; creekready/catalog.py — two-array Featherless ranking contract, request-specific ID allowlists, vetted action catalog, and fail-closed validation.</a:t>
+            </a:r>
+          </a:p>
+          <a:p xmlns:a="http://schemas.openxmlformats.org/drawingml/2006/main">
+            <a:r>
+              <a:t>- creekready/models.py — bounded request and response contracts.</a:t>
+            </a:r>
+          </a:p>
+          <a:p xmlns:a="http://schemas.openxmlformats.org/drawingml/2006/main">
+            <a:r>
+              <a:t>- README.md — exact privacy statement, modes, and current provider behavior.</a:t>
             </a:r>
           </a:p>
           <a:p xmlns:a="http://schemas.openxmlformats.org/drawingml/2006/main">
@@ -949,7 +949,7 @@
   </p:cSld>
   <p:clrMap bg1="lt1" tx1="dk1" bg2="lt2" tx2="dk2" accent1="accent1" accent2="accent2" accent3="accent3" accent4="accent4" accent5="accent5" accent6="accent6" hlink="hlink" folHlink="folHlink"/>
   <p:sldLayoutIdLst>
-    <p:sldLayoutId xmlns:r="http://schemas.openxmlformats.org/officeDocument/2006/relationships" id="2147483649" r:id="R6a321b56f9174464"/>
+    <p:sldLayoutId xmlns:r="http://schemas.openxmlformats.org/officeDocument/2006/relationships" id="2147483649" r:id="Re264e594b99b4a4a"/>
   </p:sldLayoutIdLst>
   <p:txStyles>
     <p:titleStyle>
@@ -1504,7 +1504,7 @@
           <p:nvPr/>
         </p:nvPicPr>
         <p:blipFill>
-          <a:blip xmlns:r="http://schemas.openxmlformats.org/officeDocument/2006/relationships" xmlns:a="http://schemas.openxmlformats.org/drawingml/2006/main" r:embed="Red69c21fdf32492f"/>
+          <a:blip xmlns:r="http://schemas.openxmlformats.org/officeDocument/2006/relationships" xmlns:a="http://schemas.openxmlformats.org/drawingml/2006/main" r:embed="R90fa7786feaa462c"/>
           <a:srcRect xmlns:a="http://schemas.openxmlformats.org/drawingml/2006/main" l="0" t="27" r="0" b="27"/>
           <a:stretch xmlns:a="http://schemas.openxmlformats.org/drawingml/2006/main">
             <a:fillRect l="0" t="0" r="0" b="0"/>
@@ -3289,8 +3289,8 @@
         </p:nvSpPr>
         <p:spPr>
           <a:xfrm xmlns:a="http://schemas.openxmlformats.org/drawingml/2006/main">
-            <a:off x="590550" y="990600"/>
-            <a:ext cx="10287000" cy="552450"/>
+            <a:off x="590550" y="1390650"/>
+            <a:ext cx="2266950" cy="1952625"/>
           </a:xfrm>
           <a:prstGeom xmlns:a="http://schemas.openxmlformats.org/drawingml/2006/main" prst="rect">
             <a:avLst/>
@@ -3333,7 +3333,8 @@
                 <a:ea typeface="Georgia"/>
                 <a:cs typeface="Georgia"/>
               </a:rPr>
-              <a:t>One alert becomes a plan the household can scan.</a:t>
+              <a:t>One alert.
+The whole plan in view.</a:t>
             </a:r>
           </a:p>
         </p:txBody>
@@ -3354,8 +3355,8 @@
         </p:nvSpPr>
         <p:spPr>
           <a:xfrm xmlns:a="http://schemas.openxmlformats.org/drawingml/2006/main">
-            <a:off x="590550" y="1676400"/>
-            <a:ext cx="10287000" cy="342900"/>
+            <a:off x="590550" y="3638550"/>
+            <a:ext cx="2266950" cy="1581150"/>
           </a:xfrm>
           <a:prstGeom xmlns:a="http://schemas.openxmlformats.org/drawingml/2006/main" prst="rect">
             <a:avLst/>
@@ -3398,1808 +3399,35 @@
                 <a:ea typeface="Aptos"/>
                 <a:cs typeface="Aptos"/>
               </a:rPr>
-              <a:t>Pasted alert + household constraints → trusted facts + staged actions</a:t>
-            </a:r>
-          </a:p>
-        </p:txBody>
-      </p:sp>
-      <p:sp>
-        <p:nvSpPr>
-          <p:cNvPr id="6" name="flow-arrow-input-facts">
-            <a:extLst xmlns:a="http://schemas.openxmlformats.org/drawingml/2006/main">
-              <a:ext uri="{FF2B5EF4-FFF2-40B4-BE49-F238E27FC236}">
-                <a16:creationId xmlns:a16="http://schemas.microsoft.com/office/drawing/2014/main" id="{60F2E9B4-B4CE-4F65-B237-720A1FF0DFDE}"/>
-              </a:ext>
-            </a:extLst>
-          </p:cNvPr>
-          <p:cNvSpPr>
-            <a:spLocks xmlns:a="http://schemas.openxmlformats.org/drawingml/2006/main" noGrp="1"/>
-          </p:cNvSpPr>
-          <p:nvPr/>
-        </p:nvSpPr>
-        <p:spPr>
-          <a:xfrm xmlns:a="http://schemas.openxmlformats.org/drawingml/2006/main">
-            <a:off x="3381375" y="3600450"/>
-            <a:ext cx="1000125" cy="438150"/>
-          </a:xfrm>
-          <a:prstGeom xmlns:a="http://schemas.openxmlformats.org/drawingml/2006/main" prst="rightArrow">
-            <a:avLst/>
-          </a:prstGeom>
-          <a:solidFill xmlns:a="http://schemas.openxmlformats.org/drawingml/2006/main">
-            <a:srgbClr val="F26A5A"/>
-          </a:solidFill>
-          <a:ln xmlns:a="http://schemas.openxmlformats.org/drawingml/2006/main" w="0">
-            <a:solidFill>
-              <a:srgbClr val="000000">
-                <a:alpha val="0"/>
-              </a:srgbClr>
-            </a:solidFill>
-            <a:prstDash val="solid"/>
-          </a:ln>
-        </p:spPr>
-      </p:sp>
-      <p:sp>
-        <p:nvSpPr>
-          <p:cNvPr id="7" name="flow-arrow-facts-plan">
-            <a:extLst xmlns:a="http://schemas.openxmlformats.org/drawingml/2006/main">
-              <a:ext uri="{FF2B5EF4-FFF2-40B4-BE49-F238E27FC236}">
-                <a16:creationId xmlns:a16="http://schemas.microsoft.com/office/drawing/2014/main" id="{A1A5AC8D-30EC-4505-B091-34F8B38A5016}"/>
-              </a:ext>
-            </a:extLst>
-          </p:cNvPr>
-          <p:cNvSpPr>
-            <a:spLocks xmlns:a="http://schemas.openxmlformats.org/drawingml/2006/main" noGrp="1"/>
-          </p:cNvSpPr>
-          <p:nvPr/>
-        </p:nvSpPr>
-        <p:spPr>
-          <a:xfrm xmlns:a="http://schemas.openxmlformats.org/drawingml/2006/main">
-            <a:off x="7629525" y="3600450"/>
-            <a:ext cx="1000125" cy="438150"/>
-          </a:xfrm>
-          <a:prstGeom xmlns:a="http://schemas.openxmlformats.org/drawingml/2006/main" prst="rightArrow">
-            <a:avLst/>
-          </a:prstGeom>
-          <a:solidFill xmlns:a="http://schemas.openxmlformats.org/drawingml/2006/main">
-            <a:srgbClr val="5F9A95"/>
-          </a:solidFill>
-          <a:ln xmlns:a="http://schemas.openxmlformats.org/drawingml/2006/main" w="0">
-            <a:solidFill>
-              <a:srgbClr val="000000">
-                <a:alpha val="0"/>
-              </a:srgbClr>
-            </a:solidFill>
-            <a:prstDash val="solid"/>
-          </a:ln>
-        </p:spPr>
-      </p:sp>
-      <p:sp>
-        <p:nvSpPr>
-          <p:cNvPr id="8" name="input-frame">
-            <a:extLst xmlns:a="http://schemas.openxmlformats.org/drawingml/2006/main">
-              <a:ext uri="{FF2B5EF4-FFF2-40B4-BE49-F238E27FC236}">
-                <a16:creationId xmlns:a16="http://schemas.microsoft.com/office/drawing/2014/main" id="{63C340F8-57A3-4F85-9240-140A3DBB1916}"/>
-              </a:ext>
-            </a:extLst>
-          </p:cNvPr>
-          <p:cNvSpPr>
-            <a:spLocks xmlns:a="http://schemas.openxmlformats.org/drawingml/2006/main" noGrp="1"/>
-          </p:cNvSpPr>
-          <p:nvPr/>
-        </p:nvSpPr>
-        <p:spPr>
-          <a:xfrm xmlns:a="http://schemas.openxmlformats.org/drawingml/2006/main">
-            <a:off x="590550" y="2476500"/>
-            <a:ext cx="2952750" cy="3143250"/>
+              <a:t>Real CreekReady result: Featherless-ranked actions, household fit, three stages, and official sources.</a:t>
+            </a:r>
+          </a:p>
+        </p:txBody>
+      </p:sp>
+      <p:pic>
+        <p:nvPicPr>
+          <p:cNvPr id="46" name=""/>
+          <p:cNvPicPr>
+            <a:picLocks xmlns:a="http://schemas.openxmlformats.org/drawingml/2006/main" noChangeAspect="1"/>
+          </p:cNvPicPr>
+          <p:nvPr/>
+        </p:nvPicPr>
+        <p:blipFill>
+          <a:blip xmlns:r="http://schemas.openxmlformats.org/officeDocument/2006/relationships" xmlns:a="http://schemas.openxmlformats.org/drawingml/2006/main" r:embed="R02df94a8a4924e94"/>
+          <a:stretch xmlns:a="http://schemas.openxmlformats.org/drawingml/2006/main"/>
+        </p:blipFill>
+        <p:spPr>
+          <a:xfrm xmlns:a="http://schemas.openxmlformats.org/drawingml/2006/main">
+            <a:off x="3219450" y="1238250"/>
+            <a:ext cx="8382000" cy="4714875"/>
           </a:xfrm>
           <a:prstGeom xmlns:a="http://schemas.openxmlformats.org/drawingml/2006/main" prst="roundRect">
             <a:avLst>
-              <a:gd name="adj" fmla="val 7742"/>
+              <a:gd name="adj" fmla="val 2424"/>
             </a:avLst>
           </a:prstGeom>
-          <a:solidFill xmlns:a="http://schemas.openxmlformats.org/drawingml/2006/main">
-            <a:srgbClr val="0B2433"/>
-          </a:solidFill>
-          <a:ln xmlns:a="http://schemas.openxmlformats.org/drawingml/2006/main" w="0">
-            <a:solidFill>
-              <a:srgbClr val="000000">
-                <a:alpha val="0"/>
-              </a:srgbClr>
-            </a:solidFill>
-            <a:prstDash val="solid"/>
-          </a:ln>
-        </p:spPr>
-      </p:sp>
-      <p:sp>
-        <p:nvSpPr>
-          <p:cNvPr id="9" name="input-kicker">
-            <a:extLst xmlns:a="http://schemas.openxmlformats.org/drawingml/2006/main">
-              <a:ext uri="{FF2B5EF4-FFF2-40B4-BE49-F238E27FC236}">
-                <a16:creationId xmlns:a16="http://schemas.microsoft.com/office/drawing/2014/main" id="{BD54254E-947F-425C-AA55-D48F51C4D951}"/>
-              </a:ext>
-            </a:extLst>
-          </p:cNvPr>
-          <p:cNvSpPr>
-            <a:spLocks xmlns:a="http://schemas.openxmlformats.org/drawingml/2006/main" noGrp="1"/>
-          </p:cNvSpPr>
-          <p:nvPr/>
-        </p:nvSpPr>
-        <p:spPr>
-          <a:xfrm xmlns:a="http://schemas.openxmlformats.org/drawingml/2006/main">
-            <a:off x="895350" y="2762250"/>
-            <a:ext cx="857250" cy="247650"/>
-          </a:xfrm>
-          <a:prstGeom xmlns:a="http://schemas.openxmlformats.org/drawingml/2006/main" prst="rect">
-            <a:avLst/>
-          </a:prstGeom>
-          <a:solidFill xmlns:a="http://schemas.openxmlformats.org/drawingml/2006/main">
-            <a:srgbClr val="000000">
-              <a:alpha val="0"/>
-            </a:srgbClr>
-          </a:solidFill>
-          <a:ln xmlns:a="http://schemas.openxmlformats.org/drawingml/2006/main" w="0">
-            <a:solidFill>
-              <a:srgbClr val="000000">
-                <a:alpha val="0"/>
-              </a:srgbClr>
-            </a:solidFill>
-            <a:prstDash val="solid"/>
-          </a:ln>
-        </p:spPr>
-        <p:txBody>
-          <a:bodyPr xmlns:a="http://schemas.openxmlformats.org/drawingml/2006/main" lIns="0" tIns="0" rIns="0" bIns="0" anchor="t"/>
-          <a:lstStyle xmlns:a="http://schemas.openxmlformats.org/drawingml/2006/main"/>
-          <a:p xmlns:a="http://schemas.openxmlformats.org/drawingml/2006/main">
-            <a:pPr algn="l">
-              <a:buNone/>
-              <a:defRPr sz="1200" b="1">
-                <a:solidFill>
-                  <a:srgbClr val="FFB0A4"/>
-                </a:solidFill>
-                <a:latin typeface="Aptos"/>
-                <a:ea typeface="Aptos"/>
-                <a:cs typeface="Aptos"/>
-              </a:defRPr>
-            </a:pPr>
-            <a:r>
-              <a:rPr sz="1200" b="1">
-                <a:solidFill>
-                  <a:srgbClr val="FFB0A4"/>
-                </a:solidFill>
-                <a:latin typeface="Aptos"/>
-                <a:ea typeface="Aptos"/>
-                <a:cs typeface="Aptos"/>
-              </a:rPr>
-              <a:t>INPUT</a:t>
-            </a:r>
-          </a:p>
-        </p:txBody>
-      </p:sp>
-      <p:sp>
-        <p:nvSpPr>
-          <p:cNvPr id="10" name="input-heading">
-            <a:extLst xmlns:a="http://schemas.openxmlformats.org/drawingml/2006/main">
-              <a:ext uri="{FF2B5EF4-FFF2-40B4-BE49-F238E27FC236}">
-                <a16:creationId xmlns:a16="http://schemas.microsoft.com/office/drawing/2014/main" id="{D128C1F4-39DC-44BD-B12E-9BCEC7C150E4}"/>
-              </a:ext>
-            </a:extLst>
-          </p:cNvPr>
-          <p:cNvSpPr>
-            <a:spLocks xmlns:a="http://schemas.openxmlformats.org/drawingml/2006/main" noGrp="1"/>
-          </p:cNvSpPr>
-          <p:nvPr/>
-        </p:nvSpPr>
-        <p:spPr>
-          <a:xfrm xmlns:a="http://schemas.openxmlformats.org/drawingml/2006/main">
-            <a:off x="895350" y="3105150"/>
-            <a:ext cx="2238375" cy="361950"/>
-          </a:xfrm>
-          <a:prstGeom xmlns:a="http://schemas.openxmlformats.org/drawingml/2006/main" prst="rect">
-            <a:avLst/>
-          </a:prstGeom>
-          <a:solidFill xmlns:a="http://schemas.openxmlformats.org/drawingml/2006/main">
-            <a:srgbClr val="000000">
-              <a:alpha val="0"/>
-            </a:srgbClr>
-          </a:solidFill>
-          <a:ln xmlns:a="http://schemas.openxmlformats.org/drawingml/2006/main" w="0">
-            <a:solidFill>
-              <a:srgbClr val="000000">
-                <a:alpha val="0"/>
-              </a:srgbClr>
-            </a:solidFill>
-            <a:prstDash val="solid"/>
-          </a:ln>
-        </p:spPr>
-        <p:txBody>
-          <a:bodyPr xmlns:a="http://schemas.openxmlformats.org/drawingml/2006/main" lIns="0" tIns="0" rIns="0" bIns="0" anchor="t"/>
-          <a:lstStyle xmlns:a="http://schemas.openxmlformats.org/drawingml/2006/main"/>
-          <a:p xmlns:a="http://schemas.openxmlformats.org/drawingml/2006/main">
-            <a:pPr algn="l">
-              <a:buNone/>
-              <a:defRPr sz="1950" b="1">
-                <a:solidFill>
-                  <a:srgbClr val="F5EBDD"/>
-                </a:solidFill>
-                <a:latin typeface="Aptos"/>
-                <a:ea typeface="Aptos"/>
-                <a:cs typeface="Aptos"/>
-              </a:defRPr>
-            </a:pPr>
-            <a:r>
-              <a:rPr sz="1950" b="1">
-                <a:solidFill>
-                  <a:srgbClr val="F5EBDD"/>
-                </a:solidFill>
-                <a:latin typeface="Aptos"/>
-                <a:ea typeface="Aptos"/>
-                <a:cs typeface="Aptos"/>
-              </a:rPr>
-              <a:t>Official alert text</a:t>
-            </a:r>
-          </a:p>
-        </p:txBody>
-      </p:sp>
-      <p:sp>
-        <p:nvSpPr>
-          <p:cNvPr id="11" name="input-line-1">
-            <a:extLst xmlns:a="http://schemas.openxmlformats.org/drawingml/2006/main">
-              <a:ext uri="{FF2B5EF4-FFF2-40B4-BE49-F238E27FC236}">
-                <a16:creationId xmlns:a16="http://schemas.microsoft.com/office/drawing/2014/main" id="{9986A1C5-FAF2-4BEC-A1DD-BF84AD1DF4AF}"/>
-              </a:ext>
-            </a:extLst>
-          </p:cNvPr>
-          <p:cNvSpPr>
-            <a:spLocks xmlns:a="http://schemas.openxmlformats.org/drawingml/2006/main" noGrp="1"/>
-          </p:cNvSpPr>
-          <p:nvPr/>
-        </p:nvSpPr>
-        <p:spPr>
-          <a:xfrm xmlns:a="http://schemas.openxmlformats.org/drawingml/2006/main">
-            <a:off x="895350" y="3638550"/>
-            <a:ext cx="2095500" cy="76200"/>
-          </a:xfrm>
-          <a:prstGeom xmlns:a="http://schemas.openxmlformats.org/drawingml/2006/main" prst="roundRect">
-            <a:avLst>
-              <a:gd name="adj" fmla="val 50000"/>
-            </a:avLst>
-          </a:prstGeom>
-          <a:solidFill xmlns:a="http://schemas.openxmlformats.org/drawingml/2006/main">
-            <a:srgbClr val="BCD4D6"/>
-          </a:solidFill>
-          <a:ln xmlns:a="http://schemas.openxmlformats.org/drawingml/2006/main" w="0">
-            <a:solidFill>
-              <a:srgbClr val="000000">
-                <a:alpha val="0"/>
-              </a:srgbClr>
-            </a:solidFill>
-            <a:prstDash val="solid"/>
-          </a:ln>
-        </p:spPr>
-      </p:sp>
-      <p:sp>
-        <p:nvSpPr>
-          <p:cNvPr id="12" name="input-line-2">
-            <a:extLst xmlns:a="http://schemas.openxmlformats.org/drawingml/2006/main">
-              <a:ext uri="{FF2B5EF4-FFF2-40B4-BE49-F238E27FC236}">
-                <a16:creationId xmlns:a16="http://schemas.microsoft.com/office/drawing/2014/main" id="{62D14744-856A-4DA2-8DC2-41FE850A92D7}"/>
-              </a:ext>
-            </a:extLst>
-          </p:cNvPr>
-          <p:cNvSpPr>
-            <a:spLocks xmlns:a="http://schemas.openxmlformats.org/drawingml/2006/main" noGrp="1"/>
-          </p:cNvSpPr>
-          <p:nvPr/>
-        </p:nvSpPr>
-        <p:spPr>
-          <a:xfrm xmlns:a="http://schemas.openxmlformats.org/drawingml/2006/main">
-            <a:off x="895350" y="3895725"/>
-            <a:ext cx="1809750" cy="76200"/>
-          </a:xfrm>
-          <a:prstGeom xmlns:a="http://schemas.openxmlformats.org/drawingml/2006/main" prst="roundRect">
-            <a:avLst>
-              <a:gd name="adj" fmla="val 50000"/>
-            </a:avLst>
-          </a:prstGeom>
-          <a:solidFill xmlns:a="http://schemas.openxmlformats.org/drawingml/2006/main">
-            <a:srgbClr val="BCD4D6"/>
-          </a:solidFill>
-          <a:ln xmlns:a="http://schemas.openxmlformats.org/drawingml/2006/main" w="0">
-            <a:solidFill>
-              <a:srgbClr val="000000">
-                <a:alpha val="0"/>
-              </a:srgbClr>
-            </a:solidFill>
-            <a:prstDash val="solid"/>
-          </a:ln>
-        </p:spPr>
-      </p:sp>
-      <p:sp>
-        <p:nvSpPr>
-          <p:cNvPr id="13" name="input-line-3">
-            <a:extLst xmlns:a="http://schemas.openxmlformats.org/drawingml/2006/main">
-              <a:ext uri="{FF2B5EF4-FFF2-40B4-BE49-F238E27FC236}">
-                <a16:creationId xmlns:a16="http://schemas.microsoft.com/office/drawing/2014/main" id="{1DAF5A75-8BB1-464D-BD30-0CFE63AD2347}"/>
-              </a:ext>
-            </a:extLst>
-          </p:cNvPr>
-          <p:cNvSpPr>
-            <a:spLocks xmlns:a="http://schemas.openxmlformats.org/drawingml/2006/main" noGrp="1"/>
-          </p:cNvSpPr>
-          <p:nvPr/>
-        </p:nvSpPr>
-        <p:spPr>
-          <a:xfrm xmlns:a="http://schemas.openxmlformats.org/drawingml/2006/main">
-            <a:off x="895350" y="4152900"/>
-            <a:ext cx="2247900" cy="76200"/>
-          </a:xfrm>
-          <a:prstGeom xmlns:a="http://schemas.openxmlformats.org/drawingml/2006/main" prst="roundRect">
-            <a:avLst>
-              <a:gd name="adj" fmla="val 50000"/>
-            </a:avLst>
-          </a:prstGeom>
-          <a:solidFill xmlns:a="http://schemas.openxmlformats.org/drawingml/2006/main">
-            <a:srgbClr val="BCD4D6"/>
-          </a:solidFill>
-          <a:ln xmlns:a="http://schemas.openxmlformats.org/drawingml/2006/main" w="0">
-            <a:solidFill>
-              <a:srgbClr val="000000">
-                <a:alpha val="0"/>
-              </a:srgbClr>
-            </a:solidFill>
-            <a:prstDash val="solid"/>
-          </a:ln>
-        </p:spPr>
-      </p:sp>
-      <p:sp>
-        <p:nvSpPr>
-          <p:cNvPr id="14" name="input-line-4">
-            <a:extLst xmlns:a="http://schemas.openxmlformats.org/drawingml/2006/main">
-              <a:ext uri="{FF2B5EF4-FFF2-40B4-BE49-F238E27FC236}">
-                <a16:creationId xmlns:a16="http://schemas.microsoft.com/office/drawing/2014/main" id="{3A847AB9-653C-4D6B-A73A-64DBBCF0A06D}"/>
-              </a:ext>
-            </a:extLst>
-          </p:cNvPr>
-          <p:cNvSpPr>
-            <a:spLocks xmlns:a="http://schemas.openxmlformats.org/drawingml/2006/main" noGrp="1"/>
-          </p:cNvSpPr>
-          <p:nvPr/>
-        </p:nvSpPr>
-        <p:spPr>
-          <a:xfrm xmlns:a="http://schemas.openxmlformats.org/drawingml/2006/main">
-            <a:off x="895350" y="4410075"/>
-            <a:ext cx="1562100" cy="76200"/>
-          </a:xfrm>
-          <a:prstGeom xmlns:a="http://schemas.openxmlformats.org/drawingml/2006/main" prst="roundRect">
-            <a:avLst>
-              <a:gd name="adj" fmla="val 50000"/>
-            </a:avLst>
-          </a:prstGeom>
-          <a:solidFill xmlns:a="http://schemas.openxmlformats.org/drawingml/2006/main">
-            <a:srgbClr val="BCD4D6"/>
-          </a:solidFill>
-          <a:ln xmlns:a="http://schemas.openxmlformats.org/drawingml/2006/main" w="0">
-            <a:solidFill>
-              <a:srgbClr val="000000">
-                <a:alpha val="0"/>
-              </a:srgbClr>
-            </a:solidFill>
-            <a:prstDash val="solid"/>
-          </a:ln>
-        </p:spPr>
-      </p:sp>
-      <p:sp>
-        <p:nvSpPr>
-          <p:cNvPr id="15" name="input-divider">
-            <a:extLst xmlns:a="http://schemas.openxmlformats.org/drawingml/2006/main">
-              <a:ext uri="{FF2B5EF4-FFF2-40B4-BE49-F238E27FC236}">
-                <a16:creationId xmlns:a16="http://schemas.microsoft.com/office/drawing/2014/main" id="{088AF350-1F4E-4CD9-A087-ADF33414D225}"/>
-              </a:ext>
-            </a:extLst>
-          </p:cNvPr>
-          <p:cNvSpPr>
-            <a:spLocks xmlns:a="http://schemas.openxmlformats.org/drawingml/2006/main" noGrp="1"/>
-          </p:cNvSpPr>
-          <p:nvPr/>
-        </p:nvSpPr>
-        <p:spPr>
-          <a:xfrm xmlns:a="http://schemas.openxmlformats.org/drawingml/2006/main">
-            <a:off x="895350" y="4762500"/>
-            <a:ext cx="2266950" cy="0"/>
-          </a:xfrm>
-          <a:prstGeom xmlns:a="http://schemas.openxmlformats.org/drawingml/2006/main" prst="line">
-            <a:avLst/>
-          </a:prstGeom>
-          <a:solidFill xmlns:a="http://schemas.openxmlformats.org/drawingml/2006/main">
-            <a:srgbClr val="000000">
-              <a:alpha val="0"/>
-            </a:srgbClr>
-          </a:solidFill>
-          <a:ln xmlns:a="http://schemas.openxmlformats.org/drawingml/2006/main" w="19050">
-            <a:solidFill>
-              <a:srgbClr val="5F9A95"/>
-            </a:solidFill>
-            <a:prstDash val="solid"/>
-          </a:ln>
-        </p:spPr>
-      </p:sp>
-      <p:sp>
-        <p:nvSpPr>
-          <p:cNvPr id="16" name="input-needs">
-            <a:extLst xmlns:a="http://schemas.openxmlformats.org/drawingml/2006/main">
-              <a:ext uri="{FF2B5EF4-FFF2-40B4-BE49-F238E27FC236}">
-                <a16:creationId xmlns:a16="http://schemas.microsoft.com/office/drawing/2014/main" id="{A160C392-75B7-45C6-AD38-D4A01D2EDB92}"/>
-              </a:ext>
-            </a:extLst>
-          </p:cNvPr>
-          <p:cNvSpPr>
-            <a:spLocks xmlns:a="http://schemas.openxmlformats.org/drawingml/2006/main" noGrp="1"/>
-          </p:cNvSpPr>
-          <p:nvPr/>
-        </p:nvSpPr>
-        <p:spPr>
-          <a:xfrm xmlns:a="http://schemas.openxmlformats.org/drawingml/2006/main">
-            <a:off x="895350" y="4953000"/>
-            <a:ext cx="2238375" cy="495300"/>
-          </a:xfrm>
-          <a:prstGeom xmlns:a="http://schemas.openxmlformats.org/drawingml/2006/main" prst="rect">
-            <a:avLst/>
-          </a:prstGeom>
-          <a:solidFill xmlns:a="http://schemas.openxmlformats.org/drawingml/2006/main">
-            <a:srgbClr val="000000">
-              <a:alpha val="0"/>
-            </a:srgbClr>
-          </a:solidFill>
-          <a:ln xmlns:a="http://schemas.openxmlformats.org/drawingml/2006/main" w="0">
-            <a:solidFill>
-              <a:srgbClr val="000000">
-                <a:alpha val="0"/>
-              </a:srgbClr>
-            </a:solidFill>
-            <a:prstDash val="solid"/>
-          </a:ln>
-        </p:spPr>
-        <p:txBody>
-          <a:bodyPr xmlns:a="http://schemas.openxmlformats.org/drawingml/2006/main" lIns="0" tIns="0" rIns="0" bIns="0" anchor="t"/>
-          <a:lstStyle xmlns:a="http://schemas.openxmlformats.org/drawingml/2006/main"/>
-          <a:p xmlns:a="http://schemas.openxmlformats.org/drawingml/2006/main">
-            <a:pPr algn="l">
-              <a:buNone/>
-              <a:defRPr sz="1275" b="1">
-                <a:solidFill>
-                  <a:srgbClr val="F5EBDD"/>
-                </a:solidFill>
-                <a:latin typeface="Aptos"/>
-                <a:ea typeface="Aptos"/>
-                <a:cs typeface="Aptos"/>
-              </a:defRPr>
-            </a:pPr>
-            <a:r>
-              <a:rPr sz="1275" b="1">
-                <a:solidFill>
-                  <a:srgbClr val="F5EBDD"/>
-                </a:solidFill>
-                <a:latin typeface="Aptos"/>
-                <a:ea typeface="Aptos"/>
-                <a:cs typeface="Aptos"/>
-              </a:rPr>
-              <a:t>OLDER ADULT   •   PET</a:t>
-            </a:r>
-          </a:p>
-          <a:p xmlns:a="http://schemas.openxmlformats.org/drawingml/2006/main">
-            <a:pPr algn="l">
-              <a:buNone/>
-              <a:defRPr sz="1275" b="1">
-                <a:solidFill>
-                  <a:srgbClr val="F5EBDD"/>
-                </a:solidFill>
-                <a:latin typeface="Aptos"/>
-                <a:ea typeface="Aptos"/>
-                <a:cs typeface="Aptos"/>
-              </a:defRPr>
-            </a:pPr>
-            <a:r>
-              <a:rPr sz="1275" b="1">
-                <a:solidFill>
-                  <a:srgbClr val="F5EBDD"/>
-                </a:solidFill>
-                <a:latin typeface="Aptos"/>
-                <a:ea typeface="Aptos"/>
-                <a:cs typeface="Aptos"/>
-              </a:rPr>
-              <a:t>NO VEHICLE</a:t>
-            </a:r>
-          </a:p>
-        </p:txBody>
-      </p:sp>
-      <p:sp>
-        <p:nvSpPr>
-          <p:cNvPr id="17" name="facts-frame">
-            <a:extLst xmlns:a="http://schemas.openxmlformats.org/drawingml/2006/main">
-              <a:ext uri="{FF2B5EF4-FFF2-40B4-BE49-F238E27FC236}">
-                <a16:creationId xmlns:a16="http://schemas.microsoft.com/office/drawing/2014/main" id="{DFD0A597-EC3C-4FF8-BEF1-8DC0A9081FBE}"/>
-              </a:ext>
-            </a:extLst>
-          </p:cNvPr>
-          <p:cNvSpPr>
-            <a:spLocks xmlns:a="http://schemas.openxmlformats.org/drawingml/2006/main" noGrp="1"/>
-          </p:cNvSpPr>
-          <p:nvPr/>
-        </p:nvSpPr>
-        <p:spPr>
-          <a:xfrm xmlns:a="http://schemas.openxmlformats.org/drawingml/2006/main">
-            <a:off x="4210050" y="2286000"/>
-            <a:ext cx="3590925" cy="3524250"/>
-          </a:xfrm>
-          <a:prstGeom xmlns:a="http://schemas.openxmlformats.org/drawingml/2006/main" prst="roundRect">
-            <a:avLst>
-              <a:gd name="adj" fmla="val 6486"/>
-            </a:avLst>
-          </a:prstGeom>
-          <a:solidFill xmlns:a="http://schemas.openxmlformats.org/drawingml/2006/main">
-            <a:srgbClr val="F5EBDD"/>
-          </a:solidFill>
-          <a:ln xmlns:a="http://schemas.openxmlformats.org/drawingml/2006/main" w="19050">
-            <a:solidFill>
-              <a:srgbClr val="0B2433"/>
-            </a:solidFill>
-            <a:prstDash val="solid"/>
-          </a:ln>
-        </p:spPr>
-      </p:sp>
-      <p:sp>
-        <p:nvSpPr>
-          <p:cNvPr id="18" name="facts-kicker">
-            <a:extLst xmlns:a="http://schemas.openxmlformats.org/drawingml/2006/main">
-              <a:ext uri="{FF2B5EF4-FFF2-40B4-BE49-F238E27FC236}">
-                <a16:creationId xmlns:a16="http://schemas.microsoft.com/office/drawing/2014/main" id="{FE57E968-574F-48A3-AC77-755CF7172C85}"/>
-              </a:ext>
-            </a:extLst>
-          </p:cNvPr>
-          <p:cNvSpPr>
-            <a:spLocks xmlns:a="http://schemas.openxmlformats.org/drawingml/2006/main" noGrp="1"/>
-          </p:cNvSpPr>
-          <p:nvPr/>
-        </p:nvSpPr>
-        <p:spPr>
-          <a:xfrm xmlns:a="http://schemas.openxmlformats.org/drawingml/2006/main">
-            <a:off x="4552950" y="2638425"/>
-            <a:ext cx="2095500" cy="247650"/>
-          </a:xfrm>
-          <a:prstGeom xmlns:a="http://schemas.openxmlformats.org/drawingml/2006/main" prst="rect">
-            <a:avLst/>
-          </a:prstGeom>
-          <a:solidFill xmlns:a="http://schemas.openxmlformats.org/drawingml/2006/main">
-            <a:srgbClr val="000000">
-              <a:alpha val="0"/>
-            </a:srgbClr>
-          </a:solidFill>
-          <a:ln xmlns:a="http://schemas.openxmlformats.org/drawingml/2006/main" w="0">
-            <a:solidFill>
-              <a:srgbClr val="000000">
-                <a:alpha val="0"/>
-              </a:srgbClr>
-            </a:solidFill>
-            <a:prstDash val="solid"/>
-          </a:ln>
-        </p:spPr>
-        <p:txBody>
-          <a:bodyPr xmlns:a="http://schemas.openxmlformats.org/drawingml/2006/main" lIns="0" tIns="0" rIns="0" bIns="0" anchor="t"/>
-          <a:lstStyle xmlns:a="http://schemas.openxmlformats.org/drawingml/2006/main"/>
-          <a:p xmlns:a="http://schemas.openxmlformats.org/drawingml/2006/main">
-            <a:pPr algn="l">
-              <a:buNone/>
-              <a:defRPr sz="1200" b="1">
-                <a:solidFill>
-                  <a:srgbClr val="5F9A95"/>
-                </a:solidFill>
-                <a:latin typeface="Aptos"/>
-                <a:ea typeface="Aptos"/>
-                <a:cs typeface="Aptos"/>
-              </a:defRPr>
-            </a:pPr>
-            <a:r>
-              <a:rPr sz="1200" b="1">
-                <a:solidFill>
-                  <a:srgbClr val="5F9A95"/>
-                </a:solidFill>
-                <a:latin typeface="Aptos"/>
-                <a:ea typeface="Aptos"/>
-                <a:cs typeface="Aptos"/>
-              </a:rPr>
-              <a:t>TRUSTED FACTS</a:t>
-            </a:r>
-          </a:p>
-        </p:txBody>
-      </p:sp>
-      <p:sp>
-        <p:nvSpPr>
-          <p:cNvPr id="19" name="facts-heading">
-            <a:extLst xmlns:a="http://schemas.openxmlformats.org/drawingml/2006/main">
-              <a:ext uri="{FF2B5EF4-FFF2-40B4-BE49-F238E27FC236}">
-                <a16:creationId xmlns:a16="http://schemas.microsoft.com/office/drawing/2014/main" id="{148AA410-0D57-4750-8A49-91190F26419D}"/>
-              </a:ext>
-            </a:extLst>
-          </p:cNvPr>
-          <p:cNvSpPr>
-            <a:spLocks xmlns:a="http://schemas.openxmlformats.org/drawingml/2006/main" noGrp="1"/>
-          </p:cNvSpPr>
-          <p:nvPr/>
-        </p:nvSpPr>
-        <p:spPr>
-          <a:xfrm xmlns:a="http://schemas.openxmlformats.org/drawingml/2006/main">
-            <a:off x="4552950" y="3028950"/>
-            <a:ext cx="2857500" cy="400050"/>
-          </a:xfrm>
-          <a:prstGeom xmlns:a="http://schemas.openxmlformats.org/drawingml/2006/main" prst="rect">
-            <a:avLst/>
-          </a:prstGeom>
-          <a:solidFill xmlns:a="http://schemas.openxmlformats.org/drawingml/2006/main">
-            <a:srgbClr val="000000">
-              <a:alpha val="0"/>
-            </a:srgbClr>
-          </a:solidFill>
-          <a:ln xmlns:a="http://schemas.openxmlformats.org/drawingml/2006/main" w="0">
-            <a:solidFill>
-              <a:srgbClr val="000000">
-                <a:alpha val="0"/>
-              </a:srgbClr>
-            </a:solidFill>
-            <a:prstDash val="solid"/>
-          </a:ln>
-        </p:spPr>
-        <p:txBody>
-          <a:bodyPr xmlns:a="http://schemas.openxmlformats.org/drawingml/2006/main" lIns="0" tIns="0" rIns="0" bIns="0" anchor="t"/>
-          <a:lstStyle xmlns:a="http://schemas.openxmlformats.org/drawingml/2006/main"/>
-          <a:p xmlns:a="http://schemas.openxmlformats.org/drawingml/2006/main">
-            <a:pPr algn="l">
-              <a:buNone/>
-              <a:defRPr sz="2100" b="1">
-                <a:solidFill>
-                  <a:srgbClr val="0B2433"/>
-                </a:solidFill>
-                <a:latin typeface="Georgia"/>
-                <a:ea typeface="Georgia"/>
-                <a:cs typeface="Georgia"/>
-              </a:defRPr>
-            </a:pPr>
-            <a:r>
-              <a:rPr sz="2100" b="1">
-                <a:solidFill>
-                  <a:srgbClr val="0B2433"/>
-                </a:solidFill>
-                <a:latin typeface="Georgia"/>
-                <a:ea typeface="Georgia"/>
-                <a:cs typeface="Georgia"/>
-              </a:rPr>
-              <a:t>The alert stays visible.</a:t>
-            </a:r>
-          </a:p>
-        </p:txBody>
-      </p:sp>
-      <p:sp>
-        <p:nvSpPr>
-          <p:cNvPr id="20" name="fact-label-0">
-            <a:extLst xmlns:a="http://schemas.openxmlformats.org/drawingml/2006/main">
-              <a:ext uri="{FF2B5EF4-FFF2-40B4-BE49-F238E27FC236}">
-                <a16:creationId xmlns:a16="http://schemas.microsoft.com/office/drawing/2014/main" id="{FE1218A8-DCBD-4406-9DB0-ADEE92C11A84}"/>
-              </a:ext>
-            </a:extLst>
-          </p:cNvPr>
-          <p:cNvSpPr>
-            <a:spLocks xmlns:a="http://schemas.openxmlformats.org/drawingml/2006/main" noGrp="1"/>
-          </p:cNvSpPr>
-          <p:nvPr/>
-        </p:nvSpPr>
-        <p:spPr>
-          <a:xfrm xmlns:a="http://schemas.openxmlformats.org/drawingml/2006/main">
-            <a:off x="4552950" y="3714750"/>
-            <a:ext cx="857250" cy="228600"/>
-          </a:xfrm>
-          <a:prstGeom xmlns:a="http://schemas.openxmlformats.org/drawingml/2006/main" prst="rect">
-            <a:avLst/>
-          </a:prstGeom>
-          <a:solidFill xmlns:a="http://schemas.openxmlformats.org/drawingml/2006/main">
-            <a:srgbClr val="000000">
-              <a:alpha val="0"/>
-            </a:srgbClr>
-          </a:solidFill>
-          <a:ln xmlns:a="http://schemas.openxmlformats.org/drawingml/2006/main" w="0">
-            <a:solidFill>
-              <a:srgbClr val="000000">
-                <a:alpha val="0"/>
-              </a:srgbClr>
-            </a:solidFill>
-            <a:prstDash val="solid"/>
-          </a:ln>
-        </p:spPr>
-        <p:txBody>
-          <a:bodyPr xmlns:a="http://schemas.openxmlformats.org/drawingml/2006/main" lIns="0" tIns="0" rIns="0" bIns="0" anchor="t"/>
-          <a:lstStyle xmlns:a="http://schemas.openxmlformats.org/drawingml/2006/main"/>
-          <a:p xmlns:a="http://schemas.openxmlformats.org/drawingml/2006/main">
-            <a:pPr algn="l">
-              <a:buNone/>
-              <a:defRPr sz="1200" b="1">
-                <a:solidFill>
-                  <a:srgbClr val="F26A5A"/>
-                </a:solidFill>
-                <a:latin typeface="Aptos"/>
-                <a:ea typeface="Aptos"/>
-                <a:cs typeface="Aptos"/>
-              </a:defRPr>
-            </a:pPr>
-            <a:r>
-              <a:rPr sz="1200" b="1">
-                <a:solidFill>
-                  <a:srgbClr val="F26A5A"/>
-                </a:solidFill>
-                <a:latin typeface="Aptos"/>
-                <a:ea typeface="Aptos"/>
-                <a:cs typeface="Aptos"/>
-              </a:rPr>
-              <a:t>HAZARD</a:t>
-            </a:r>
-          </a:p>
-        </p:txBody>
-      </p:sp>
-      <p:sp>
-        <p:nvSpPr>
-          <p:cNvPr id="21" name="fact-value-0">
-            <a:extLst xmlns:a="http://schemas.openxmlformats.org/drawingml/2006/main">
-              <a:ext uri="{FF2B5EF4-FFF2-40B4-BE49-F238E27FC236}">
-                <a16:creationId xmlns:a16="http://schemas.microsoft.com/office/drawing/2014/main" id="{0CBF0D84-9EDE-4DD3-9299-D4E6C1A0B27E}"/>
-              </a:ext>
-            </a:extLst>
-          </p:cNvPr>
-          <p:cNvSpPr>
-            <a:spLocks xmlns:a="http://schemas.openxmlformats.org/drawingml/2006/main" noGrp="1"/>
-          </p:cNvSpPr>
-          <p:nvPr/>
-        </p:nvSpPr>
-        <p:spPr>
-          <a:xfrm xmlns:a="http://schemas.openxmlformats.org/drawingml/2006/main">
-            <a:off x="5505450" y="3695700"/>
-            <a:ext cx="1905000" cy="285750"/>
-          </a:xfrm>
-          <a:prstGeom xmlns:a="http://schemas.openxmlformats.org/drawingml/2006/main" prst="rect">
-            <a:avLst/>
-          </a:prstGeom>
-          <a:solidFill xmlns:a="http://schemas.openxmlformats.org/drawingml/2006/main">
-            <a:srgbClr val="000000">
-              <a:alpha val="0"/>
-            </a:srgbClr>
-          </a:solidFill>
-          <a:ln xmlns:a="http://schemas.openxmlformats.org/drawingml/2006/main" w="0">
-            <a:solidFill>
-              <a:srgbClr val="000000">
-                <a:alpha val="0"/>
-              </a:srgbClr>
-            </a:solidFill>
-            <a:prstDash val="solid"/>
-          </a:ln>
-        </p:spPr>
-        <p:txBody>
-          <a:bodyPr xmlns:a="http://schemas.openxmlformats.org/drawingml/2006/main" lIns="0" tIns="0" rIns="0" bIns="0" anchor="t"/>
-          <a:lstStyle xmlns:a="http://schemas.openxmlformats.org/drawingml/2006/main"/>
-          <a:p xmlns:a="http://schemas.openxmlformats.org/drawingml/2006/main">
-            <a:pPr algn="l">
-              <a:buNone/>
-              <a:defRPr sz="1500" b="1">
-                <a:solidFill>
-                  <a:srgbClr val="10232F"/>
-                </a:solidFill>
-                <a:latin typeface="Aptos"/>
-                <a:ea typeface="Aptos"/>
-                <a:cs typeface="Aptos"/>
-              </a:defRPr>
-            </a:pPr>
-            <a:r>
-              <a:rPr sz="1500" b="1">
-                <a:solidFill>
-                  <a:srgbClr val="10232F"/>
-                </a:solidFill>
-                <a:latin typeface="Aptos"/>
-                <a:ea typeface="Aptos"/>
-                <a:cs typeface="Aptos"/>
-              </a:rPr>
-              <a:t>Wildfire warning</a:t>
-            </a:r>
-          </a:p>
-        </p:txBody>
-      </p:sp>
-      <p:sp>
-        <p:nvSpPr>
-          <p:cNvPr id="22" name="fact-label-1">
-            <a:extLst xmlns:a="http://schemas.openxmlformats.org/drawingml/2006/main">
-              <a:ext uri="{FF2B5EF4-FFF2-40B4-BE49-F238E27FC236}">
-                <a16:creationId xmlns:a16="http://schemas.microsoft.com/office/drawing/2014/main" id="{1FBADE29-C017-4BD3-BC07-8163547ECA52}"/>
-              </a:ext>
-            </a:extLst>
-          </p:cNvPr>
-          <p:cNvSpPr>
-            <a:spLocks xmlns:a="http://schemas.openxmlformats.org/drawingml/2006/main" noGrp="1"/>
-          </p:cNvSpPr>
-          <p:nvPr/>
-        </p:nvSpPr>
-        <p:spPr>
-          <a:xfrm xmlns:a="http://schemas.openxmlformats.org/drawingml/2006/main">
-            <a:off x="4552950" y="4286250"/>
-            <a:ext cx="857250" cy="228600"/>
-          </a:xfrm>
-          <a:prstGeom xmlns:a="http://schemas.openxmlformats.org/drawingml/2006/main" prst="rect">
-            <a:avLst/>
-          </a:prstGeom>
-          <a:solidFill xmlns:a="http://schemas.openxmlformats.org/drawingml/2006/main">
-            <a:srgbClr val="000000">
-              <a:alpha val="0"/>
-            </a:srgbClr>
-          </a:solidFill>
-          <a:ln xmlns:a="http://schemas.openxmlformats.org/drawingml/2006/main" w="0">
-            <a:solidFill>
-              <a:srgbClr val="000000">
-                <a:alpha val="0"/>
-              </a:srgbClr>
-            </a:solidFill>
-            <a:prstDash val="solid"/>
-          </a:ln>
-        </p:spPr>
-        <p:txBody>
-          <a:bodyPr xmlns:a="http://schemas.openxmlformats.org/drawingml/2006/main" lIns="0" tIns="0" rIns="0" bIns="0" anchor="t"/>
-          <a:lstStyle xmlns:a="http://schemas.openxmlformats.org/drawingml/2006/main"/>
-          <a:p xmlns:a="http://schemas.openxmlformats.org/drawingml/2006/main">
-            <a:pPr algn="l">
-              <a:buNone/>
-              <a:defRPr sz="1200" b="1">
-                <a:solidFill>
-                  <a:srgbClr val="F26A5A"/>
-                </a:solidFill>
-                <a:latin typeface="Aptos"/>
-                <a:ea typeface="Aptos"/>
-                <a:cs typeface="Aptos"/>
-              </a:defRPr>
-            </a:pPr>
-            <a:r>
-              <a:rPr sz="1200" b="1">
-                <a:solidFill>
-                  <a:srgbClr val="F26A5A"/>
-                </a:solidFill>
-                <a:latin typeface="Aptos"/>
-                <a:ea typeface="Aptos"/>
-                <a:cs typeface="Aptos"/>
-              </a:rPr>
-              <a:t>PLACE</a:t>
-            </a:r>
-          </a:p>
-        </p:txBody>
-      </p:sp>
-      <p:sp>
-        <p:nvSpPr>
-          <p:cNvPr id="23" name="fact-value-1">
-            <a:extLst xmlns:a="http://schemas.openxmlformats.org/drawingml/2006/main">
-              <a:ext uri="{FF2B5EF4-FFF2-40B4-BE49-F238E27FC236}">
-                <a16:creationId xmlns:a16="http://schemas.microsoft.com/office/drawing/2014/main" id="{5692FF34-4F96-47EB-9B47-730080D5A124}"/>
-              </a:ext>
-            </a:extLst>
-          </p:cNvPr>
-          <p:cNvSpPr>
-            <a:spLocks xmlns:a="http://schemas.openxmlformats.org/drawingml/2006/main" noGrp="1"/>
-          </p:cNvSpPr>
-          <p:nvPr/>
-        </p:nvSpPr>
-        <p:spPr>
-          <a:xfrm xmlns:a="http://schemas.openxmlformats.org/drawingml/2006/main">
-            <a:off x="5505450" y="4267200"/>
-            <a:ext cx="1905000" cy="285750"/>
-          </a:xfrm>
-          <a:prstGeom xmlns:a="http://schemas.openxmlformats.org/drawingml/2006/main" prst="rect">
-            <a:avLst/>
-          </a:prstGeom>
-          <a:solidFill xmlns:a="http://schemas.openxmlformats.org/drawingml/2006/main">
-            <a:srgbClr val="000000">
-              <a:alpha val="0"/>
-            </a:srgbClr>
-          </a:solidFill>
-          <a:ln xmlns:a="http://schemas.openxmlformats.org/drawingml/2006/main" w="0">
-            <a:solidFill>
-              <a:srgbClr val="000000">
-                <a:alpha val="0"/>
-              </a:srgbClr>
-            </a:solidFill>
-            <a:prstDash val="solid"/>
-          </a:ln>
-        </p:spPr>
-        <p:txBody>
-          <a:bodyPr xmlns:a="http://schemas.openxmlformats.org/drawingml/2006/main" lIns="0" tIns="0" rIns="0" bIns="0" anchor="t"/>
-          <a:lstStyle xmlns:a="http://schemas.openxmlformats.org/drawingml/2006/main"/>
-          <a:p xmlns:a="http://schemas.openxmlformats.org/drawingml/2006/main">
-            <a:pPr algn="l">
-              <a:buNone/>
-              <a:defRPr sz="1500" b="1">
-                <a:solidFill>
-                  <a:srgbClr val="10232F"/>
-                </a:solidFill>
-                <a:latin typeface="Aptos"/>
-                <a:ea typeface="Aptos"/>
-                <a:cs typeface="Aptos"/>
-              </a:defRPr>
-            </a:pPr>
-            <a:r>
-              <a:rPr sz="1500" b="1">
-                <a:solidFill>
-                  <a:srgbClr val="10232F"/>
-                </a:solidFill>
-                <a:latin typeface="Aptos"/>
-                <a:ea typeface="Aptos"/>
-                <a:cs typeface="Aptos"/>
-              </a:rPr>
-              <a:t>Area stated in alert</a:t>
-            </a:r>
-          </a:p>
-        </p:txBody>
-      </p:sp>
-      <p:sp>
-        <p:nvSpPr>
-          <p:cNvPr id="24" name="fact-label-2">
-            <a:extLst xmlns:a="http://schemas.openxmlformats.org/drawingml/2006/main">
-              <a:ext uri="{FF2B5EF4-FFF2-40B4-BE49-F238E27FC236}">
-                <a16:creationId xmlns:a16="http://schemas.microsoft.com/office/drawing/2014/main" id="{FE597350-19B0-415F-B8AD-ECFA4B270C5D}"/>
-              </a:ext>
-            </a:extLst>
-          </p:cNvPr>
-          <p:cNvSpPr>
-            <a:spLocks xmlns:a="http://schemas.openxmlformats.org/drawingml/2006/main" noGrp="1"/>
-          </p:cNvSpPr>
-          <p:nvPr/>
-        </p:nvSpPr>
-        <p:spPr>
-          <a:xfrm xmlns:a="http://schemas.openxmlformats.org/drawingml/2006/main">
-            <a:off x="4552950" y="4857750"/>
-            <a:ext cx="857250" cy="228600"/>
-          </a:xfrm>
-          <a:prstGeom xmlns:a="http://schemas.openxmlformats.org/drawingml/2006/main" prst="rect">
-            <a:avLst/>
-          </a:prstGeom>
-          <a:solidFill xmlns:a="http://schemas.openxmlformats.org/drawingml/2006/main">
-            <a:srgbClr val="000000">
-              <a:alpha val="0"/>
-            </a:srgbClr>
-          </a:solidFill>
-          <a:ln xmlns:a="http://schemas.openxmlformats.org/drawingml/2006/main" w="0">
-            <a:solidFill>
-              <a:srgbClr val="000000">
-                <a:alpha val="0"/>
-              </a:srgbClr>
-            </a:solidFill>
-            <a:prstDash val="solid"/>
-          </a:ln>
-        </p:spPr>
-        <p:txBody>
-          <a:bodyPr xmlns:a="http://schemas.openxmlformats.org/drawingml/2006/main" lIns="0" tIns="0" rIns="0" bIns="0" anchor="t"/>
-          <a:lstStyle xmlns:a="http://schemas.openxmlformats.org/drawingml/2006/main"/>
-          <a:p xmlns:a="http://schemas.openxmlformats.org/drawingml/2006/main">
-            <a:pPr algn="l">
-              <a:buNone/>
-              <a:defRPr sz="1200" b="1">
-                <a:solidFill>
-                  <a:srgbClr val="F26A5A"/>
-                </a:solidFill>
-                <a:latin typeface="Aptos"/>
-                <a:ea typeface="Aptos"/>
-                <a:cs typeface="Aptos"/>
-              </a:defRPr>
-            </a:pPr>
-            <a:r>
-              <a:rPr sz="1200" b="1">
-                <a:solidFill>
-                  <a:srgbClr val="F26A5A"/>
-                </a:solidFill>
-                <a:latin typeface="Aptos"/>
-                <a:ea typeface="Aptos"/>
-                <a:cs typeface="Aptos"/>
-              </a:rPr>
-              <a:t>TIMING</a:t>
-            </a:r>
-          </a:p>
-        </p:txBody>
-      </p:sp>
-      <p:sp>
-        <p:nvSpPr>
-          <p:cNvPr id="25" name="fact-value-2">
-            <a:extLst xmlns:a="http://schemas.openxmlformats.org/drawingml/2006/main">
-              <a:ext uri="{FF2B5EF4-FFF2-40B4-BE49-F238E27FC236}">
-                <a16:creationId xmlns:a16="http://schemas.microsoft.com/office/drawing/2014/main" id="{825EB5C5-656A-4A93-AE84-B93B078906BA}"/>
-              </a:ext>
-            </a:extLst>
-          </p:cNvPr>
-          <p:cNvSpPr>
-            <a:spLocks xmlns:a="http://schemas.openxmlformats.org/drawingml/2006/main" noGrp="1"/>
-          </p:cNvSpPr>
-          <p:nvPr/>
-        </p:nvSpPr>
-        <p:spPr>
-          <a:xfrm xmlns:a="http://schemas.openxmlformats.org/drawingml/2006/main">
-            <a:off x="5505450" y="4838700"/>
-            <a:ext cx="1905000" cy="285750"/>
-          </a:xfrm>
-          <a:prstGeom xmlns:a="http://schemas.openxmlformats.org/drawingml/2006/main" prst="rect">
-            <a:avLst/>
-          </a:prstGeom>
-          <a:solidFill xmlns:a="http://schemas.openxmlformats.org/drawingml/2006/main">
-            <a:srgbClr val="000000">
-              <a:alpha val="0"/>
-            </a:srgbClr>
-          </a:solidFill>
-          <a:ln xmlns:a="http://schemas.openxmlformats.org/drawingml/2006/main" w="0">
-            <a:solidFill>
-              <a:srgbClr val="000000">
-                <a:alpha val="0"/>
-              </a:srgbClr>
-            </a:solidFill>
-            <a:prstDash val="solid"/>
-          </a:ln>
-        </p:spPr>
-        <p:txBody>
-          <a:bodyPr xmlns:a="http://schemas.openxmlformats.org/drawingml/2006/main" lIns="0" tIns="0" rIns="0" bIns="0" anchor="t"/>
-          <a:lstStyle xmlns:a="http://schemas.openxmlformats.org/drawingml/2006/main"/>
-          <a:p xmlns:a="http://schemas.openxmlformats.org/drawingml/2006/main">
-            <a:pPr algn="l">
-              <a:buNone/>
-              <a:defRPr sz="1500" b="1">
-                <a:solidFill>
-                  <a:srgbClr val="10232F"/>
-                </a:solidFill>
-                <a:latin typeface="Aptos"/>
-                <a:ea typeface="Aptos"/>
-                <a:cs typeface="Aptos"/>
-              </a:defRPr>
-            </a:pPr>
-            <a:r>
-              <a:rPr sz="1500" b="1">
-                <a:solidFill>
-                  <a:srgbClr val="10232F"/>
-                </a:solidFill>
-                <a:latin typeface="Aptos"/>
-                <a:ea typeface="Aptos"/>
-                <a:cs typeface="Aptos"/>
-              </a:rPr>
-              <a:t>Window stated in alert</a:t>
-            </a:r>
-          </a:p>
-        </p:txBody>
-      </p:sp>
-      <p:sp>
-        <p:nvSpPr>
-          <p:cNvPr id="26" name="facts-note">
-            <a:extLst xmlns:a="http://schemas.openxmlformats.org/drawingml/2006/main">
-              <a:ext uri="{FF2B5EF4-FFF2-40B4-BE49-F238E27FC236}">
-                <a16:creationId xmlns:a16="http://schemas.microsoft.com/office/drawing/2014/main" id="{A6454B4B-695A-4D56-AD22-AE00C2C93C23}"/>
-              </a:ext>
-            </a:extLst>
-          </p:cNvPr>
-          <p:cNvSpPr>
-            <a:spLocks xmlns:a="http://schemas.openxmlformats.org/drawingml/2006/main" noGrp="1"/>
-          </p:cNvSpPr>
-          <p:nvPr/>
-        </p:nvSpPr>
-        <p:spPr>
-          <a:xfrm xmlns:a="http://schemas.openxmlformats.org/drawingml/2006/main">
-            <a:off x="4552950" y="5400675"/>
-            <a:ext cx="2905125" cy="228600"/>
-          </a:xfrm>
-          <a:prstGeom xmlns:a="http://schemas.openxmlformats.org/drawingml/2006/main" prst="rect">
-            <a:avLst/>
-          </a:prstGeom>
-          <a:solidFill xmlns:a="http://schemas.openxmlformats.org/drawingml/2006/main">
-            <a:srgbClr val="000000">
-              <a:alpha val="0"/>
-            </a:srgbClr>
-          </a:solidFill>
-          <a:ln xmlns:a="http://schemas.openxmlformats.org/drawingml/2006/main" w="0">
-            <a:solidFill>
-              <a:srgbClr val="000000">
-                <a:alpha val="0"/>
-              </a:srgbClr>
-            </a:solidFill>
-            <a:prstDash val="solid"/>
-          </a:ln>
-        </p:spPr>
-        <p:txBody>
-          <a:bodyPr xmlns:a="http://schemas.openxmlformats.org/drawingml/2006/main" lIns="0" tIns="0" rIns="0" bIns="0" anchor="t"/>
-          <a:lstStyle xmlns:a="http://schemas.openxmlformats.org/drawingml/2006/main"/>
-          <a:p xmlns:a="http://schemas.openxmlformats.org/drawingml/2006/main">
-            <a:pPr algn="l">
-              <a:buNone/>
-              <a:defRPr sz="1200" b="0">
-                <a:solidFill>
-                  <a:srgbClr val="143849"/>
-                </a:solidFill>
-                <a:latin typeface="Aptos"/>
-                <a:ea typeface="Aptos"/>
-                <a:cs typeface="Aptos"/>
-              </a:defRPr>
-            </a:pPr>
-            <a:r>
-              <a:rPr sz="1200" b="0">
-                <a:solidFill>
-                  <a:srgbClr val="143849"/>
-                </a:solidFill>
-                <a:latin typeface="Aptos"/>
-                <a:ea typeface="Aptos"/>
-                <a:cs typeface="Aptos"/>
-              </a:rPr>
-              <a:t>Deterministic—not model-authored—facts</a:t>
-            </a:r>
-          </a:p>
-        </p:txBody>
-      </p:sp>
-      <p:sp>
-        <p:nvSpPr>
-          <p:cNvPr id="27" name="plan-frame">
-            <a:extLst xmlns:a="http://schemas.openxmlformats.org/drawingml/2006/main">
-              <a:ext uri="{FF2B5EF4-FFF2-40B4-BE49-F238E27FC236}">
-                <a16:creationId xmlns:a16="http://schemas.microsoft.com/office/drawing/2014/main" id="{3DFF4B26-13B0-4DC6-9432-710F68ECCE98}"/>
-              </a:ext>
-            </a:extLst>
-          </p:cNvPr>
-          <p:cNvSpPr>
-            <a:spLocks xmlns:a="http://schemas.openxmlformats.org/drawingml/2006/main" noGrp="1"/>
-          </p:cNvSpPr>
-          <p:nvPr/>
-        </p:nvSpPr>
-        <p:spPr>
-          <a:xfrm xmlns:a="http://schemas.openxmlformats.org/drawingml/2006/main">
-            <a:off x="8439150" y="2286000"/>
-            <a:ext cx="3162300" cy="3524250"/>
-          </a:xfrm>
-          <a:prstGeom xmlns:a="http://schemas.openxmlformats.org/drawingml/2006/main" prst="roundRect">
-            <a:avLst>
-              <a:gd name="adj" fmla="val 7229"/>
-            </a:avLst>
-          </a:prstGeom>
-          <a:solidFill xmlns:a="http://schemas.openxmlformats.org/drawingml/2006/main">
-            <a:srgbClr val="DDE7E5"/>
-          </a:solidFill>
-          <a:ln xmlns:a="http://schemas.openxmlformats.org/drawingml/2006/main" w="0">
-            <a:solidFill>
-              <a:srgbClr val="000000">
-                <a:alpha val="0"/>
-              </a:srgbClr>
-            </a:solidFill>
-            <a:prstDash val="solid"/>
-          </a:ln>
-        </p:spPr>
-      </p:sp>
-      <p:sp>
-        <p:nvSpPr>
-          <p:cNvPr id="28" name="plan-kicker">
-            <a:extLst xmlns:a="http://schemas.openxmlformats.org/drawingml/2006/main">
-              <a:ext uri="{FF2B5EF4-FFF2-40B4-BE49-F238E27FC236}">
-                <a16:creationId xmlns:a16="http://schemas.microsoft.com/office/drawing/2014/main" id="{5B1410BE-5414-498C-92AB-F640694A2390}"/>
-              </a:ext>
-            </a:extLst>
-          </p:cNvPr>
-          <p:cNvSpPr>
-            <a:spLocks xmlns:a="http://schemas.openxmlformats.org/drawingml/2006/main" noGrp="1"/>
-          </p:cNvSpPr>
-          <p:nvPr/>
-        </p:nvSpPr>
-        <p:spPr>
-          <a:xfrm xmlns:a="http://schemas.openxmlformats.org/drawingml/2006/main">
-            <a:off x="8743950" y="2638425"/>
-            <a:ext cx="2000250" cy="247650"/>
-          </a:xfrm>
-          <a:prstGeom xmlns:a="http://schemas.openxmlformats.org/drawingml/2006/main" prst="rect">
-            <a:avLst/>
-          </a:prstGeom>
-          <a:solidFill xmlns:a="http://schemas.openxmlformats.org/drawingml/2006/main">
-            <a:srgbClr val="000000">
-              <a:alpha val="0"/>
-            </a:srgbClr>
-          </a:solidFill>
-          <a:ln xmlns:a="http://schemas.openxmlformats.org/drawingml/2006/main" w="0">
-            <a:solidFill>
-              <a:srgbClr val="000000">
-                <a:alpha val="0"/>
-              </a:srgbClr>
-            </a:solidFill>
-            <a:prstDash val="solid"/>
-          </a:ln>
-        </p:spPr>
-        <p:txBody>
-          <a:bodyPr xmlns:a="http://schemas.openxmlformats.org/drawingml/2006/main" lIns="0" tIns="0" rIns="0" bIns="0" anchor="t"/>
-          <a:lstStyle xmlns:a="http://schemas.openxmlformats.org/drawingml/2006/main"/>
-          <a:p xmlns:a="http://schemas.openxmlformats.org/drawingml/2006/main">
-            <a:pPr algn="l">
-              <a:buNone/>
-              <a:defRPr sz="1200" b="1">
-                <a:solidFill>
-                  <a:srgbClr val="143849"/>
-                </a:solidFill>
-                <a:latin typeface="Aptos"/>
-                <a:ea typeface="Aptos"/>
-                <a:cs typeface="Aptos"/>
-              </a:defRPr>
-            </a:pPr>
-            <a:r>
-              <a:rPr sz="1200" b="1">
-                <a:solidFill>
-                  <a:srgbClr val="143849"/>
-                </a:solidFill>
-                <a:latin typeface="Aptos"/>
-                <a:ea typeface="Aptos"/>
-                <a:cs typeface="Aptos"/>
-              </a:rPr>
-              <a:t>HOUSEHOLD PLAN</a:t>
-            </a:r>
-          </a:p>
-        </p:txBody>
-      </p:sp>
-      <p:sp>
-        <p:nvSpPr>
-          <p:cNvPr id="29" name="stage-band-0">
-            <a:extLst xmlns:a="http://schemas.openxmlformats.org/drawingml/2006/main">
-              <a:ext uri="{FF2B5EF4-FFF2-40B4-BE49-F238E27FC236}">
-                <a16:creationId xmlns:a16="http://schemas.microsoft.com/office/drawing/2014/main" id="{1A8CFDAC-0012-4AA7-8B2C-960E17D963C3}"/>
-              </a:ext>
-            </a:extLst>
-          </p:cNvPr>
-          <p:cNvSpPr>
-            <a:spLocks xmlns:a="http://schemas.openxmlformats.org/drawingml/2006/main" noGrp="1"/>
-          </p:cNvSpPr>
-          <p:nvPr/>
-        </p:nvSpPr>
-        <p:spPr>
-          <a:xfrm xmlns:a="http://schemas.openxmlformats.org/drawingml/2006/main">
-            <a:off x="8743950" y="3143250"/>
-            <a:ext cx="2552700" cy="628650"/>
-          </a:xfrm>
-          <a:prstGeom xmlns:a="http://schemas.openxmlformats.org/drawingml/2006/main" prst="roundRect">
-            <a:avLst>
-              <a:gd name="adj" fmla="val 24242"/>
-            </a:avLst>
-          </a:prstGeom>
-          <a:solidFill xmlns:a="http://schemas.openxmlformats.org/drawingml/2006/main">
-            <a:srgbClr val="F26A5A"/>
-          </a:solidFill>
-          <a:ln xmlns:a="http://schemas.openxmlformats.org/drawingml/2006/main" w="0">
-            <a:solidFill>
-              <a:srgbClr val="000000">
-                <a:alpha val="0"/>
-              </a:srgbClr>
-            </a:solidFill>
-            <a:prstDash val="solid"/>
-          </a:ln>
-        </p:spPr>
-      </p:sp>
-      <p:sp>
-        <p:nvSpPr>
-          <p:cNvPr id="30" name="stage-label-0">
-            <a:extLst xmlns:a="http://schemas.openxmlformats.org/drawingml/2006/main">
-              <a:ext uri="{FF2B5EF4-FFF2-40B4-BE49-F238E27FC236}">
-                <a16:creationId xmlns:a16="http://schemas.microsoft.com/office/drawing/2014/main" id="{ED7FCDED-75CB-4FD9-9E22-290B716C8FA1}"/>
-              </a:ext>
-            </a:extLst>
-          </p:cNvPr>
-          <p:cNvSpPr>
-            <a:spLocks xmlns:a="http://schemas.openxmlformats.org/drawingml/2006/main" noGrp="1"/>
-          </p:cNvSpPr>
-          <p:nvPr/>
-        </p:nvSpPr>
-        <p:spPr>
-          <a:xfrm xmlns:a="http://schemas.openxmlformats.org/drawingml/2006/main">
-            <a:off x="8915400" y="3228975"/>
-            <a:ext cx="876300" cy="209550"/>
-          </a:xfrm>
-          <a:prstGeom xmlns:a="http://schemas.openxmlformats.org/drawingml/2006/main" prst="rect">
-            <a:avLst/>
-          </a:prstGeom>
-          <a:solidFill xmlns:a="http://schemas.openxmlformats.org/drawingml/2006/main">
-            <a:srgbClr val="000000">
-              <a:alpha val="0"/>
-            </a:srgbClr>
-          </a:solidFill>
-          <a:ln xmlns:a="http://schemas.openxmlformats.org/drawingml/2006/main" w="0">
-            <a:solidFill>
-              <a:srgbClr val="000000">
-                <a:alpha val="0"/>
-              </a:srgbClr>
-            </a:solidFill>
-            <a:prstDash val="solid"/>
-          </a:ln>
-        </p:spPr>
-        <p:txBody>
-          <a:bodyPr xmlns:a="http://schemas.openxmlformats.org/drawingml/2006/main" lIns="0" tIns="0" rIns="0" bIns="0" anchor="t"/>
-          <a:lstStyle xmlns:a="http://schemas.openxmlformats.org/drawingml/2006/main"/>
-          <a:p xmlns:a="http://schemas.openxmlformats.org/drawingml/2006/main">
-            <a:pPr algn="l">
-              <a:buNone/>
-              <a:defRPr sz="1200" b="1">
-                <a:solidFill>
-                  <a:srgbClr val="FFFFFF"/>
-                </a:solidFill>
-                <a:latin typeface="Aptos"/>
-                <a:ea typeface="Aptos"/>
-                <a:cs typeface="Aptos"/>
-              </a:defRPr>
-            </a:pPr>
-            <a:r>
-              <a:rPr sz="1200" b="1">
-                <a:solidFill>
-                  <a:srgbClr val="FFFFFF"/>
-                </a:solidFill>
-                <a:latin typeface="Aptos"/>
-                <a:ea typeface="Aptos"/>
-                <a:cs typeface="Aptos"/>
-              </a:rPr>
-              <a:t>NOW</a:t>
-            </a:r>
-          </a:p>
-        </p:txBody>
-      </p:sp>
-      <p:sp>
-        <p:nvSpPr>
-          <p:cNvPr id="31" name="stage-value-0">
-            <a:extLst xmlns:a="http://schemas.openxmlformats.org/drawingml/2006/main">
-              <a:ext uri="{FF2B5EF4-FFF2-40B4-BE49-F238E27FC236}">
-                <a16:creationId xmlns:a16="http://schemas.microsoft.com/office/drawing/2014/main" id="{556FA747-88D8-47DA-8D29-5FA783990D67}"/>
-              </a:ext>
-            </a:extLst>
-          </p:cNvPr>
-          <p:cNvSpPr>
-            <a:spLocks xmlns:a="http://schemas.openxmlformats.org/drawingml/2006/main" noGrp="1"/>
-          </p:cNvSpPr>
-          <p:nvPr/>
-        </p:nvSpPr>
-        <p:spPr>
-          <a:xfrm xmlns:a="http://schemas.openxmlformats.org/drawingml/2006/main">
-            <a:off x="8915400" y="3448050"/>
-            <a:ext cx="2190750" cy="228600"/>
-          </a:xfrm>
-          <a:prstGeom xmlns:a="http://schemas.openxmlformats.org/drawingml/2006/main" prst="rect">
-            <a:avLst/>
-          </a:prstGeom>
-          <a:solidFill xmlns:a="http://schemas.openxmlformats.org/drawingml/2006/main">
-            <a:srgbClr val="000000">
-              <a:alpha val="0"/>
-            </a:srgbClr>
-          </a:solidFill>
-          <a:ln xmlns:a="http://schemas.openxmlformats.org/drawingml/2006/main" w="0">
-            <a:solidFill>
-              <a:srgbClr val="000000">
-                <a:alpha val="0"/>
-              </a:srgbClr>
-            </a:solidFill>
-            <a:prstDash val="solid"/>
-          </a:ln>
-        </p:spPr>
-        <p:txBody>
-          <a:bodyPr xmlns:a="http://schemas.openxmlformats.org/drawingml/2006/main" lIns="0" tIns="0" rIns="0" bIns="0" anchor="t"/>
-          <a:lstStyle xmlns:a="http://schemas.openxmlformats.org/drawingml/2006/main"/>
-          <a:p xmlns:a="http://schemas.openxmlformats.org/drawingml/2006/main">
-            <a:pPr algn="l">
-              <a:buNone/>
-              <a:defRPr sz="1350" b="1">
-                <a:solidFill>
-                  <a:srgbClr val="FFFFFF"/>
-                </a:solidFill>
-                <a:latin typeface="Aptos"/>
-                <a:ea typeface="Aptos"/>
-                <a:cs typeface="Aptos"/>
-              </a:defRPr>
-            </a:pPr>
-            <a:r>
-              <a:rPr sz="1350" b="1">
-                <a:solidFill>
-                  <a:srgbClr val="FFFFFF"/>
-                </a:solidFill>
-                <a:latin typeface="Aptos"/>
-                <a:ea typeface="Aptos"/>
-                <a:cs typeface="Aptos"/>
-              </a:rPr>
-              <a:t>Follow the alert first</a:t>
-            </a:r>
-          </a:p>
-        </p:txBody>
-      </p:sp>
-      <p:sp>
-        <p:nvSpPr>
-          <p:cNvPr id="32" name="stage-band-1">
-            <a:extLst xmlns:a="http://schemas.openxmlformats.org/drawingml/2006/main">
-              <a:ext uri="{FF2B5EF4-FFF2-40B4-BE49-F238E27FC236}">
-                <a16:creationId xmlns:a16="http://schemas.microsoft.com/office/drawing/2014/main" id="{F9E80055-124D-43B4-AEE0-592B423CB5CD}"/>
-              </a:ext>
-            </a:extLst>
-          </p:cNvPr>
-          <p:cNvSpPr>
-            <a:spLocks xmlns:a="http://schemas.openxmlformats.org/drawingml/2006/main" noGrp="1"/>
-          </p:cNvSpPr>
-          <p:nvPr/>
-        </p:nvSpPr>
-        <p:spPr>
-          <a:xfrm xmlns:a="http://schemas.openxmlformats.org/drawingml/2006/main">
-            <a:off x="8743950" y="3943350"/>
-            <a:ext cx="2552700" cy="628650"/>
-          </a:xfrm>
-          <a:prstGeom xmlns:a="http://schemas.openxmlformats.org/drawingml/2006/main" prst="roundRect">
-            <a:avLst>
-              <a:gd name="adj" fmla="val 24242"/>
-            </a:avLst>
-          </a:prstGeom>
-          <a:solidFill xmlns:a="http://schemas.openxmlformats.org/drawingml/2006/main">
-            <a:srgbClr val="5F9A95"/>
-          </a:solidFill>
-          <a:ln xmlns:a="http://schemas.openxmlformats.org/drawingml/2006/main" w="0">
-            <a:solidFill>
-              <a:srgbClr val="000000">
-                <a:alpha val="0"/>
-              </a:srgbClr>
-            </a:solidFill>
-            <a:prstDash val="solid"/>
-          </a:ln>
-        </p:spPr>
-      </p:sp>
-      <p:sp>
-        <p:nvSpPr>
-          <p:cNvPr id="33" name="stage-label-1">
-            <a:extLst xmlns:a="http://schemas.openxmlformats.org/drawingml/2006/main">
-              <a:ext uri="{FF2B5EF4-FFF2-40B4-BE49-F238E27FC236}">
-                <a16:creationId xmlns:a16="http://schemas.microsoft.com/office/drawing/2014/main" id="{CAFC31C5-04E8-4655-A99D-744A9A174475}"/>
-              </a:ext>
-            </a:extLst>
-          </p:cNvPr>
-          <p:cNvSpPr>
-            <a:spLocks xmlns:a="http://schemas.openxmlformats.org/drawingml/2006/main" noGrp="1"/>
-          </p:cNvSpPr>
-          <p:nvPr/>
-        </p:nvSpPr>
-        <p:spPr>
-          <a:xfrm xmlns:a="http://schemas.openxmlformats.org/drawingml/2006/main">
-            <a:off x="8915400" y="4029075"/>
-            <a:ext cx="876300" cy="209550"/>
-          </a:xfrm>
-          <a:prstGeom xmlns:a="http://schemas.openxmlformats.org/drawingml/2006/main" prst="rect">
-            <a:avLst/>
-          </a:prstGeom>
-          <a:solidFill xmlns:a="http://schemas.openxmlformats.org/drawingml/2006/main">
-            <a:srgbClr val="000000">
-              <a:alpha val="0"/>
-            </a:srgbClr>
-          </a:solidFill>
-          <a:ln xmlns:a="http://schemas.openxmlformats.org/drawingml/2006/main" w="0">
-            <a:solidFill>
-              <a:srgbClr val="000000">
-                <a:alpha val="0"/>
-              </a:srgbClr>
-            </a:solidFill>
-            <a:prstDash val="solid"/>
-          </a:ln>
-        </p:spPr>
-        <p:txBody>
-          <a:bodyPr xmlns:a="http://schemas.openxmlformats.org/drawingml/2006/main" lIns="0" tIns="0" rIns="0" bIns="0" anchor="t"/>
-          <a:lstStyle xmlns:a="http://schemas.openxmlformats.org/drawingml/2006/main"/>
-          <a:p xmlns:a="http://schemas.openxmlformats.org/drawingml/2006/main">
-            <a:pPr algn="l">
-              <a:buNone/>
-              <a:defRPr sz="1200" b="1">
-                <a:solidFill>
-                  <a:srgbClr val="FFFFFF"/>
-                </a:solidFill>
-                <a:latin typeface="Aptos"/>
-                <a:ea typeface="Aptos"/>
-                <a:cs typeface="Aptos"/>
-              </a:defRPr>
-            </a:pPr>
-            <a:r>
-              <a:rPr sz="1200" b="1">
-                <a:solidFill>
-                  <a:srgbClr val="FFFFFF"/>
-                </a:solidFill>
-                <a:latin typeface="Aptos"/>
-                <a:ea typeface="Aptos"/>
-                <a:cs typeface="Aptos"/>
-              </a:rPr>
-              <a:t>NEXT</a:t>
-            </a:r>
-          </a:p>
-        </p:txBody>
-      </p:sp>
-      <p:sp>
-        <p:nvSpPr>
-          <p:cNvPr id="34" name="stage-value-1">
-            <a:extLst xmlns:a="http://schemas.openxmlformats.org/drawingml/2006/main">
-              <a:ext uri="{FF2B5EF4-FFF2-40B4-BE49-F238E27FC236}">
-                <a16:creationId xmlns:a16="http://schemas.microsoft.com/office/drawing/2014/main" id="{58FCFE46-EF63-4B99-A59A-7C81C5CC341A}"/>
-              </a:ext>
-            </a:extLst>
-          </p:cNvPr>
-          <p:cNvSpPr>
-            <a:spLocks xmlns:a="http://schemas.openxmlformats.org/drawingml/2006/main" noGrp="1"/>
-          </p:cNvSpPr>
-          <p:nvPr/>
-        </p:nvSpPr>
-        <p:spPr>
-          <a:xfrm xmlns:a="http://schemas.openxmlformats.org/drawingml/2006/main">
-            <a:off x="8915400" y="4248150"/>
-            <a:ext cx="2190750" cy="228600"/>
-          </a:xfrm>
-          <a:prstGeom xmlns:a="http://schemas.openxmlformats.org/drawingml/2006/main" prst="rect">
-            <a:avLst/>
-          </a:prstGeom>
-          <a:solidFill xmlns:a="http://schemas.openxmlformats.org/drawingml/2006/main">
-            <a:srgbClr val="000000">
-              <a:alpha val="0"/>
-            </a:srgbClr>
-          </a:solidFill>
-          <a:ln xmlns:a="http://schemas.openxmlformats.org/drawingml/2006/main" w="0">
-            <a:solidFill>
-              <a:srgbClr val="000000">
-                <a:alpha val="0"/>
-              </a:srgbClr>
-            </a:solidFill>
-            <a:prstDash val="solid"/>
-          </a:ln>
-        </p:spPr>
-        <p:txBody>
-          <a:bodyPr xmlns:a="http://schemas.openxmlformats.org/drawingml/2006/main" lIns="0" tIns="0" rIns="0" bIns="0" anchor="t"/>
-          <a:lstStyle xmlns:a="http://schemas.openxmlformats.org/drawingml/2006/main"/>
-          <a:p xmlns:a="http://schemas.openxmlformats.org/drawingml/2006/main">
-            <a:pPr algn="l">
-              <a:buNone/>
-              <a:defRPr sz="1350" b="1">
-                <a:solidFill>
-                  <a:srgbClr val="FFFFFF"/>
-                </a:solidFill>
-                <a:latin typeface="Aptos"/>
-                <a:ea typeface="Aptos"/>
-                <a:cs typeface="Aptos"/>
-              </a:defRPr>
-            </a:pPr>
-            <a:r>
-              <a:rPr sz="1350" b="1">
-                <a:solidFill>
-                  <a:srgbClr val="FFFFFF"/>
-                </a:solidFill>
-                <a:latin typeface="Aptos"/>
-                <a:ea typeface="Aptos"/>
-                <a:cs typeface="Aptos"/>
-              </a:rPr>
-              <a:t>Stage household needs</a:t>
-            </a:r>
-          </a:p>
-        </p:txBody>
-      </p:sp>
-      <p:sp>
-        <p:nvSpPr>
-          <p:cNvPr id="35" name="stage-band-2">
-            <a:extLst xmlns:a="http://schemas.openxmlformats.org/drawingml/2006/main">
-              <a:ext uri="{FF2B5EF4-FFF2-40B4-BE49-F238E27FC236}">
-                <a16:creationId xmlns:a16="http://schemas.microsoft.com/office/drawing/2014/main" id="{4D260999-63C3-468E-8A2B-5B91805EB510}"/>
-              </a:ext>
-            </a:extLst>
-          </p:cNvPr>
-          <p:cNvSpPr>
-            <a:spLocks xmlns:a="http://schemas.openxmlformats.org/drawingml/2006/main" noGrp="1"/>
-          </p:cNvSpPr>
-          <p:nvPr/>
-        </p:nvSpPr>
-        <p:spPr>
-          <a:xfrm xmlns:a="http://schemas.openxmlformats.org/drawingml/2006/main">
-            <a:off x="8743950" y="4743450"/>
-            <a:ext cx="2552700" cy="628650"/>
-          </a:xfrm>
-          <a:prstGeom xmlns:a="http://schemas.openxmlformats.org/drawingml/2006/main" prst="roundRect">
-            <a:avLst>
-              <a:gd name="adj" fmla="val 24242"/>
-            </a:avLst>
-          </a:prstGeom>
-          <a:solidFill xmlns:a="http://schemas.openxmlformats.org/drawingml/2006/main">
-            <a:srgbClr val="0B2433"/>
-          </a:solidFill>
-          <a:ln xmlns:a="http://schemas.openxmlformats.org/drawingml/2006/main" w="0">
-            <a:solidFill>
-              <a:srgbClr val="000000">
-                <a:alpha val="0"/>
-              </a:srgbClr>
-            </a:solidFill>
-            <a:prstDash val="solid"/>
-          </a:ln>
-        </p:spPr>
-      </p:sp>
-      <p:sp>
-        <p:nvSpPr>
-          <p:cNvPr id="36" name="stage-label-2">
-            <a:extLst xmlns:a="http://schemas.openxmlformats.org/drawingml/2006/main">
-              <a:ext uri="{FF2B5EF4-FFF2-40B4-BE49-F238E27FC236}">
-                <a16:creationId xmlns:a16="http://schemas.microsoft.com/office/drawing/2014/main" id="{D37EED1B-A5A3-42B4-AB5A-C415F9C90AA7}"/>
-              </a:ext>
-            </a:extLst>
-          </p:cNvPr>
-          <p:cNvSpPr>
-            <a:spLocks xmlns:a="http://schemas.openxmlformats.org/drawingml/2006/main" noGrp="1"/>
-          </p:cNvSpPr>
-          <p:nvPr/>
-        </p:nvSpPr>
-        <p:spPr>
-          <a:xfrm xmlns:a="http://schemas.openxmlformats.org/drawingml/2006/main">
-            <a:off x="8915400" y="4829175"/>
-            <a:ext cx="876300" cy="209550"/>
-          </a:xfrm>
-          <a:prstGeom xmlns:a="http://schemas.openxmlformats.org/drawingml/2006/main" prst="rect">
-            <a:avLst/>
-          </a:prstGeom>
-          <a:solidFill xmlns:a="http://schemas.openxmlformats.org/drawingml/2006/main">
-            <a:srgbClr val="000000">
-              <a:alpha val="0"/>
-            </a:srgbClr>
-          </a:solidFill>
-          <a:ln xmlns:a="http://schemas.openxmlformats.org/drawingml/2006/main" w="0">
-            <a:solidFill>
-              <a:srgbClr val="000000">
-                <a:alpha val="0"/>
-              </a:srgbClr>
-            </a:solidFill>
-            <a:prstDash val="solid"/>
-          </a:ln>
-        </p:spPr>
-        <p:txBody>
-          <a:bodyPr xmlns:a="http://schemas.openxmlformats.org/drawingml/2006/main" lIns="0" tIns="0" rIns="0" bIns="0" anchor="t"/>
-          <a:lstStyle xmlns:a="http://schemas.openxmlformats.org/drawingml/2006/main"/>
-          <a:p xmlns:a="http://schemas.openxmlformats.org/drawingml/2006/main">
-            <a:pPr algn="l">
-              <a:buNone/>
-              <a:defRPr sz="1200" b="1">
-                <a:solidFill>
-                  <a:srgbClr val="F5EBDD"/>
-                </a:solidFill>
-                <a:latin typeface="Aptos"/>
-                <a:ea typeface="Aptos"/>
-                <a:cs typeface="Aptos"/>
-              </a:defRPr>
-            </a:pPr>
-            <a:r>
-              <a:rPr sz="1200" b="1">
-                <a:solidFill>
-                  <a:srgbClr val="F5EBDD"/>
-                </a:solidFill>
-                <a:latin typeface="Aptos"/>
-                <a:ea typeface="Aptos"/>
-                <a:cs typeface="Aptos"/>
-              </a:rPr>
-              <a:t>IF WORSE</a:t>
-            </a:r>
-          </a:p>
-        </p:txBody>
-      </p:sp>
-      <p:sp>
-        <p:nvSpPr>
-          <p:cNvPr id="37" name="stage-value-2">
-            <a:extLst xmlns:a="http://schemas.openxmlformats.org/drawingml/2006/main">
-              <a:ext uri="{FF2B5EF4-FFF2-40B4-BE49-F238E27FC236}">
-                <a16:creationId xmlns:a16="http://schemas.microsoft.com/office/drawing/2014/main" id="{077138B6-6796-48FD-998B-FFD05CC16D51}"/>
-              </a:ext>
-            </a:extLst>
-          </p:cNvPr>
-          <p:cNvSpPr>
-            <a:spLocks xmlns:a="http://schemas.openxmlformats.org/drawingml/2006/main" noGrp="1"/>
-          </p:cNvSpPr>
-          <p:nvPr/>
-        </p:nvSpPr>
-        <p:spPr>
-          <a:xfrm xmlns:a="http://schemas.openxmlformats.org/drawingml/2006/main">
-            <a:off x="8915400" y="5048250"/>
-            <a:ext cx="2190750" cy="228600"/>
-          </a:xfrm>
-          <a:prstGeom xmlns:a="http://schemas.openxmlformats.org/drawingml/2006/main" prst="rect">
-            <a:avLst/>
-          </a:prstGeom>
-          <a:solidFill xmlns:a="http://schemas.openxmlformats.org/drawingml/2006/main">
-            <a:srgbClr val="000000">
-              <a:alpha val="0"/>
-            </a:srgbClr>
-          </a:solidFill>
-          <a:ln xmlns:a="http://schemas.openxmlformats.org/drawingml/2006/main" w="0">
-            <a:solidFill>
-              <a:srgbClr val="000000">
-                <a:alpha val="0"/>
-              </a:srgbClr>
-            </a:solidFill>
-            <a:prstDash val="solid"/>
-          </a:ln>
-        </p:spPr>
-        <p:txBody>
-          <a:bodyPr xmlns:a="http://schemas.openxmlformats.org/drawingml/2006/main" lIns="0" tIns="0" rIns="0" bIns="0" anchor="t"/>
-          <a:lstStyle xmlns:a="http://schemas.openxmlformats.org/drawingml/2006/main"/>
-          <a:p xmlns:a="http://schemas.openxmlformats.org/drawingml/2006/main">
-            <a:pPr algn="l">
-              <a:buNone/>
-              <a:defRPr sz="1350" b="1">
-                <a:solidFill>
-                  <a:srgbClr val="F5EBDD"/>
-                </a:solidFill>
-                <a:latin typeface="Aptos"/>
-                <a:ea typeface="Aptos"/>
-                <a:cs typeface="Aptos"/>
-              </a:defRPr>
-            </a:pPr>
-            <a:r>
-              <a:rPr sz="1350" b="1">
-                <a:solidFill>
-                  <a:srgbClr val="F5EBDD"/>
-                </a:solidFill>
-                <a:latin typeface="Aptos"/>
-                <a:ea typeface="Aptos"/>
-                <a:cs typeface="Aptos"/>
-              </a:rPr>
-              <a:t>Defer to officials</a:t>
-            </a:r>
-          </a:p>
-        </p:txBody>
-      </p:sp>
-      <p:sp>
-        <p:nvSpPr>
-          <p:cNvPr id="38" name="plan-source-note">
-            <a:extLst xmlns:a="http://schemas.openxmlformats.org/drawingml/2006/main">
-              <a:ext uri="{FF2B5EF4-FFF2-40B4-BE49-F238E27FC236}">
-                <a16:creationId xmlns:a16="http://schemas.microsoft.com/office/drawing/2014/main" id="{9EC83574-7CFF-4878-9C47-BBC2E02B3D71}"/>
-              </a:ext>
-            </a:extLst>
-          </p:cNvPr>
-          <p:cNvSpPr>
-            <a:spLocks xmlns:a="http://schemas.openxmlformats.org/drawingml/2006/main" noGrp="1"/>
-          </p:cNvSpPr>
-          <p:nvPr/>
-        </p:nvSpPr>
-        <p:spPr>
-          <a:xfrm xmlns:a="http://schemas.openxmlformats.org/drawingml/2006/main">
-            <a:off x="8743950" y="5505450"/>
-            <a:ext cx="2571750" cy="228600"/>
-          </a:xfrm>
-          <a:prstGeom xmlns:a="http://schemas.openxmlformats.org/drawingml/2006/main" prst="rect">
-            <a:avLst/>
-          </a:prstGeom>
-          <a:solidFill xmlns:a="http://schemas.openxmlformats.org/drawingml/2006/main">
-            <a:srgbClr val="000000">
-              <a:alpha val="0"/>
-            </a:srgbClr>
-          </a:solidFill>
-          <a:ln xmlns:a="http://schemas.openxmlformats.org/drawingml/2006/main" w="0">
-            <a:solidFill>
-              <a:srgbClr val="000000">
-                <a:alpha val="0"/>
-              </a:srgbClr>
-            </a:solidFill>
-            <a:prstDash val="solid"/>
-          </a:ln>
-        </p:spPr>
-        <p:txBody>
-          <a:bodyPr xmlns:a="http://schemas.openxmlformats.org/drawingml/2006/main" lIns="0" tIns="0" rIns="0" bIns="0" anchor="t"/>
-          <a:lstStyle xmlns:a="http://schemas.openxmlformats.org/drawingml/2006/main"/>
-          <a:p xmlns:a="http://schemas.openxmlformats.org/drawingml/2006/main">
-            <a:pPr algn="l">
-              <a:buNone/>
-              <a:defRPr sz="1200" b="0">
-                <a:solidFill>
-                  <a:srgbClr val="143849"/>
-                </a:solidFill>
-                <a:latin typeface="Aptos"/>
-                <a:ea typeface="Aptos"/>
-                <a:cs typeface="Aptos"/>
-              </a:defRPr>
-            </a:pPr>
-            <a:r>
-              <a:rPr sz="1200" b="0">
-                <a:solidFill>
-                  <a:srgbClr val="143849"/>
-                </a:solidFill>
-                <a:latin typeface="Aptos"/>
-                <a:ea typeface="Aptos"/>
-                <a:cs typeface="Aptos"/>
-              </a:rPr>
-              <a:t>Every action keeps its source IDs.</a:t>
-            </a:r>
-          </a:p>
-        </p:txBody>
-      </p:sp>
+        </p:spPr>
+      </p:pic>
     </p:spTree>
     <p:extLst>
       <p:ext uri="{BB962C8B-B14F-4D97-AF65-F5344CB8AC3E}">
@@ -6088,7 +4316,7 @@
                 <a:ea typeface="Aptos"/>
                 <a:cs typeface="Aptos"/>
               </a:rPr>
-              <a:t>Featherless can order approved action IDs; it cannot author new emergency actions.</a:t>
+              <a:t>Featherless orders exact instruction and action IDs; it cannot author visible guidance.</a:t>
             </a:r>
           </a:p>
         </p:txBody>
@@ -6320,7 +4548,7 @@
                 <a:ea typeface="Aptos"/>
                 <a:cs typeface="Aptos"/>
               </a:rPr>
-              <a:t>Schema rules and a source allowlist reject malformed or unknown selections.</a:t>
+              <a:t>Schema rules and request-specific allowlists reject malformed, unknown, duplicate, or extra output.</a:t>
             </a:r>
           </a:p>
         </p:txBody>

</xml_diff>